<commit_message>
Figures from the author's mark-up of 2026-10-23
- Fig. 1a, Fig. 3a: laid out in editable Fig1a.pptx / Fig3a.pptx (author's revised layout) and placed from
  their 600-dpi exports at the former panel positions; two small fixes (USD t^-1 superscript, space before 'with').
- Fig. 1f, Fig. 3e: rank axes between labels and markers; Fig. 3e labels moved outwards.
- Fig. 3c: group headers centred over their rules; rule under the table.
- Fig. 2a: active-site render above the zoom cone (Fig2a.pptx z-order).
- Fig. 2b,c: larger markers, heavier error bars and stems; label halos; c: vertical rule left of the key.
- Fig. 2d-f: cleaner markers (white-edged fills, open no-limit circles, light stems), leader rings, labels
  moved off the data (e: plant choice to the left, STY leader below the title; f: legend off the title).
- Captions unchanged (still accurate); audit 357/0; overlap audit clean.

Co-Authored-By: Claude Opus 5.5 <noreply@anthropic.com>
</commit_message>
<xml_diff>
--- a/figures/composite/fig_field/Fig2a.pptx
+++ b/figures/composite/fig_field/Fig2a.pptx
@@ -5756,30 +5756,6 @@
             <a:chExt cx="5743" cy="1469"/>
           </a:xfrm>
         </p:grpSpPr>
-        <p:pic>
-          <p:nvPicPr>
-            <p:cNvPr id="35" name="Picture 34" descr="_trim_surface.png"/>
-            <p:cNvPicPr>
-              <a:picLocks noChangeAspect="1"/>
-            </p:cNvPicPr>
-            <p:nvPr/>
-          </p:nvPicPr>
-          <p:blipFill>
-            <a:blip r:embed="rId6"/>
-            <a:stretch>
-              <a:fillRect/>
-            </a:stretch>
-          </p:blipFill>
-          <p:spPr>
-            <a:xfrm>
-              <a:off x="567" y="2084"/>
-              <a:ext cx="1178" cy="1034"/>
-            </a:xfrm>
-            <a:prstGeom prst="rect">
-              <a:avLst/>
-            </a:prstGeom>
-          </p:spPr>
-        </p:pic>
         <p:pic>
           <p:nvPicPr>
             <p:cNvPr id="38" name="Picture 37" descr="_trim_converter.png"/>
@@ -6366,6 +6342,30 @@
             </a:fontRef>
           </p:style>
         </p:cxnSp>
+        <p:pic>
+          <p:nvPicPr>
+            <p:cNvPr id="35" name="Picture 34" descr="_trim_surface.png"/>
+            <p:cNvPicPr>
+              <a:picLocks noChangeAspect="1"/>
+            </p:cNvPicPr>
+            <p:nvPr/>
+          </p:nvPicPr>
+          <p:blipFill>
+            <a:blip r:embed="rId6"/>
+            <a:stretch>
+              <a:fillRect/>
+            </a:stretch>
+          </p:blipFill>
+          <p:spPr>
+            <a:xfrm>
+              <a:off x="567" y="2084"/>
+              <a:ext cx="1178" cy="1034"/>
+            </a:xfrm>
+            <a:prstGeom prst="rect">
+              <a:avLst/>
+            </a:prstGeom>
+          </p:spPr>
+        </p:pic>
       </p:grpSp>
     </p:spTree>
   </p:cSld>

</xml_diff>